<commit_message>
docs: refresh Monday presentation status
</commit_message>
<xml_diff>
--- a/deliverables/course5-monday-presentation.pptx
+++ b/deliverables/course5-monday-presentation.pptx
@@ -4562,7 +4562,7 @@
                 </a:solidFill>
                 <a:latin typeface="Microsoft YaHei"/>
               </a:rPr>
-              <a:t>当前状态：G0 本地基线通过；G1/G2 只读证据待补齐</a:t>
+              <a:t>当前状态：G0 本地基线通过；G1/G2 只读排查完成，等待课程数据入口</a:t>
             </a:r>
           </a:p>
         </p:txBody>
@@ -6171,7 +6171,7 @@
                           </a:solidFill>
                           <a:latin typeface="Microsoft YaHei"/>
                         </a:rPr>
-                        <a:t>记录搜索范围，查课程共享项目，再集中提问</a:t>
+                        <a:t>两区域排查已留证据；已向老师提交精确问题，等待回复</a:t>
                       </a:r>
                     </a:p>
                   </a:txBody>
@@ -6609,7 +6609,7 @@
                 </a:solidFill>
                 <a:latin typeface="Microsoft YaHei"/>
               </a:rPr>
-              <a:t>下一步先完成 G1/G2：DCS 数据字段与候选镜像实例证据</a:t>
+              <a:t>下一步：老师回复入口后补 G1（路径/字段/物种），再开实例补 G2</a:t>
             </a:r>
           </a:p>
           <a:p>
@@ -6863,7 +6863,7 @@
         <p:spPr>
           <a:xfrm>
             <a:off x="749808" y="1353312"/>
-            <a:ext cx="10195560" cy="3566159"/>
+            <a:ext cx="10195560" cy="4096511"/>
           </a:xfrm>
           <a:prstGeom prst="rect">
             <a:avLst/>
@@ -6948,7 +6948,7 @@
                 </a:solidFill>
                 <a:latin typeface="Microsoft YaHei"/>
               </a:rPr>
-              <a:t>已完成：47 个单元测试、合成 smoke test、预算与契约检查通过</a:t>
+              <a:t>已完成：本地基线全绿；DCS 两区域只读排查完成（课程数据 0 命中）</a:t>
             </a:r>
           </a:p>
           <a:p>
@@ -6967,7 +6967,26 @@
                 </a:solidFill>
                 <a:latin typeface="Microsoft YaHei"/>
               </a:rPr>
-              <a:t>阻塞项：DCS 数据路径、字段、实例内版本、正式 kBET 仍待只读核验</a:t>
+              <a:t>阻塞项：课程数据入口待老师回复；实例内版本与正式 kBET 待开实例核验</a:t>
+            </a:r>
+          </a:p>
+          <a:p>
+            <a:pPr>
+              <a:lnSpc>
+                <a:spcPct val="112000"/>
+              </a:lnSpc>
+              <a:spcAft>
+                <a:spcPts val="900"/>
+              </a:spcAft>
+            </a:pPr>
+            <a:r>
+              <a:rPr sz="1500">
+                <a:solidFill>
+                  <a:srgbClr val="1D2731"/>
+                </a:solidFill>
+                <a:latin typeface="Microsoft YaHei"/>
+              </a:rPr>
+              <a:t>镜像候选：SATURN--22/--21 页面同栈；平台无预置 kBET 镜像</a:t>
             </a:r>
           </a:p>
           <a:p>
@@ -9946,7 +9965,7 @@
         </p:nvSpPr>
         <p:spPr>
           <a:xfrm>
-            <a:off x="749808" y="4480560"/>
+            <a:off x="749808" y="2148840"/>
             <a:ext cx="10195560" cy="3035808"/>
           </a:xfrm>
           <a:prstGeom prst="rect">

</xml_diff>